<commit_message>
ClaudeFinanceLab reviews 1g, 2 and 3: exit-multiple basis, selected comps range
DCF review (DCF Model Builder):
- Report the implied exit multiple on a FY2029 year-end basis (10.3x); keep 9.9x mid-year
- New WACC x exit-multiple grid (sens_wacc_exit_multiple.csv); price implies 35x FY2029 EBITDA
- Raw-beta cross-check ($351); terminal FCF uplift explained; stub shown both ways
- Excel: year-end multiple, market EV / FY2029 EBITDA, new reconciliation check (ALL OK)

Comps review (Comparable Company Analysis):
- Walmart-alone column; selected range anchored on Tier 1 with Walmart ceiling (~$450-$690)
- EV/Revenue and P/S shown but not used; dollar stores as reference only
- Albertsons/Sprouts/PriceSmart rationale, EBITDAR and DLTR limitations, sum-of-the-parts test

Forecast follow-up: FCF definition (SBC add-back) and interest assumptions added to packet 03.
Memo, deck, football field and README updated. 101 tests pass.
</commit_message>
<xml_diff>
--- a/outputs/COST_Equity_Research_Deck.pptx
+++ b/outputs/COST_Equity_Research_Deck.pptx
@@ -202,7 +202,7 @@
                     <c:v>Comps: EV/Revenue, peer 25th–75th   $330–423</c:v>
                   </c:pt>
                   <c:pt idx="6">
-                    <c:v>Walmart &amp; BJ's multiples   $452–548</c:v>
+                    <c:v>Comps: Walmart &amp; BJ's, selected   $452–688</c:v>
                   </c:pt>
                   <c:pt idx="7">
                     <c:v>7% growth for 10 to 100 more years   $411–780</c:v>
@@ -315,7 +315,7 @@
                     <c:v>Comps: EV/Revenue, peer 25th–75th   $330–423</c:v>
                   </c:pt>
                   <c:pt idx="6">
-                    <c:v>Walmart &amp; BJ's multiples   $452–548</c:v>
+                    <c:v>Comps: Walmart &amp; BJ's, selected   $452–688</c:v>
                   </c:pt>
                   <c:pt idx="7">
                     <c:v>7% growth for 10 to 100 more years   $411–780</c:v>
@@ -349,7 +349,7 @@
                   <c:v>92.59899999999999</c:v>
                 </c:pt>
                 <c:pt idx="6">
-                  <c:v>95.464</c:v>
+                  <c:v>235.26399999999995</c:v>
                 </c:pt>
                 <c:pt idx="7">
                   <c:v>369.289</c:v>
@@ -428,7 +428,7 @@
                     <c:v>Comps: EV/Revenue, peer 25th–75th   $330–423</c:v>
                   </c:pt>
                   <c:pt idx="6">
-                    <c:v>Walmart &amp; BJ's multiples   $452–548</c:v>
+                    <c:v>Comps: Walmart &amp; BJ's, selected   $452–688</c:v>
                   </c:pt>
                   <c:pt idx="7">
                     <c:v>7% growth for 10 to 100 more years   $411–780</c:v>
@@ -1175,7 +1175,7 @@
           <a:p>
             <a:r>
               <a:rPr lang="en-US" dirty="0"/>
-              <a:t>Football field of every valuation method. Base-case DCF $337 (WACC 8.38%, terminal growth 3.0%). Peer-median multiples imply $240 (EV/EBITDA) and $280 (P/E); Walmart and BJ's multiples $452–548. Even 7% growth for 100 years after FY2029 gives only $780. Operating sensitivities move value only $299–380.</a:t>
+              <a:t>Football field of every valuation method. Base-case DCF $337 (WACC 8.38%, terminal growth 3.0%). Peer-median multiples imply $240 (EV/EBITDA) and $280 (P/E); Walmart and BJ's multiples $452–688. Even 7% growth for 100 years after FY2029 gives only $780. Operating sensitivities move value only $299–380.</a:t>
             </a:r>
             <a:endParaRPr lang="en-US" dirty="0"/>
           </a:p>
@@ -3367,7 +3367,7 @@
                 <a:ea typeface="Calibri" pitchFamily="34" charset="-122"/>
                 <a:cs typeface="Calibri" pitchFamily="34" charset="-120"/>
               </a:rPr>
-              <a:t>Growth 3.0%, reinvestment set by a 25% return on new capital; 9.9x FY2029 EBITDA.</a:t>
+              <a:t>Growth 3.0%, reinvestment set by a 25% return on new capital; 10.3x FY2029 EBITDA at year-end.</a:t>
             </a:r>
             <a:endParaRPr lang="en-US" sz="950" dirty="0"/>
           </a:p>
@@ -4176,7 +4176,7 @@
                 <a:ea typeface="Calibri" pitchFamily="34" charset="-122"/>
                 <a:cs typeface="Calibri" pitchFamily="34" charset="-120"/>
               </a:rPr>
-              <a:t>A fall toward $452–548, where Walmart and BJ's multiples would value Costco.</a:t>
+              <a:t>A fall toward $452–688, the comps range anchored on Walmart and BJ's.</a:t>
             </a:r>
             <a:endParaRPr lang="en-US" sz="1200" dirty="0"/>
           </a:p>

</xml_diff>

<commit_message>
ClaudeFinanceLab review 4 (IC memo): align ROIC, implied-growth and WACC wording across memo and deck
</commit_message>
<xml_diff>
--- a/outputs/COST_Equity_Research_Deck.pptx
+++ b/outputs/COST_Equity_Research_Deck.pptx
@@ -2465,7 +2465,7 @@
                 <a:ea typeface="Calibri" pitchFamily="34" charset="-122"/>
                 <a:cs typeface="Calibri" pitchFamily="34" charset="-120"/>
               </a:rPr>
-              <a:t>Fewer than 4,000 SKUs, suppliers paid after goods sell and fees collected upfront: working capital is −4.8% of revenue and ROIC ~33%.</a:t>
+              <a:t>Fewer than 4,000 SKUs, suppliers paid after goods sell and fees collected upfront: working capital is −4.8% of revenue and ROIC 33% in FY2024.</a:t>
             </a:r>
             <a:endParaRPr lang="en-US" sz="1150" dirty="0"/>
           </a:p>
@@ -4250,7 +4250,7 @@
                 <a:ea typeface="Calibri" pitchFamily="34" charset="-122"/>
                 <a:cs typeface="Calibri" pitchFamily="34" charset="-120"/>
               </a:rPr>
-              <a:t>A lasting fall in rates or risk premia. Each 0.5pp off WACC adds only ~$33/share; the price needs 4.8%.</a:t>
+              <a:t>A lasting fall in rates or risk premia. Near the base, 0.5pp off WACC adds ~$33/share (more as WACC falls: 6.0% gives ~$596); the price needs 4.8%.</a:t>
             </a:r>
             <a:endParaRPr lang="en-US" sz="1200" dirty="0"/>
           </a:p>

</xml_diff>

<commit_message>
Add PriceSmart (PSMT) to Tier 1 comps (review 3e)
- Config: PSMT (CIK 1041803) in settings.json and peers.json (Tier 1)
- sec_fetch: --only option to add a company without re-downloading everything
- Market data: PSMT daily and monthly prices (Yahoo, checksum-verified, in manifest)
- Comps: PSMT 8.9x EV/EBITDA, 20.3x P/E. Tier 1 median now BJ's (13.2x / 23.9x);
  selected range ~$360-$690 (was ~$450-$690). Peer median 8.8x / 18.4x
- Peer-beta WACC cross-check 7.50% / $400 (was 7.23% / $425); DCF unchanged at $337
- Excel Comps sheet handles any number of peers, adds Walmart column and a check;
  Summary uses the selected range. Charts 12 and 14, memo, deck, README, docs updated
</commit_message>
<xml_diff>
--- a/outputs/COST_Equity_Research_Deck.pptx
+++ b/outputs/COST_Equity_Research_Deck.pptx
@@ -193,16 +193,16 @@
                     <c:v>DCF: WACC and growth ±0.5pp   $294–398</c:v>
                   </c:pt>
                   <c:pt idx="3">
-                    <c:v>Comps: EV/EBITDA, peer 25th–75th   $208–359</c:v>
+                    <c:v>Comps: EV/EBITDA, peer 25th–75th   $216–331</c:v>
                   </c:pt>
                   <c:pt idx="4">
-                    <c:v>Comps: P/E, peer 25th–75th   $252–408</c:v>
+                    <c:v>Comps: P/E, peer 25th–75th   $259–393</c:v>
                   </c:pt>
                   <c:pt idx="5">
-                    <c:v>Comps: EV/Revenue, peer 25th–75th   $330–423</c:v>
+                    <c:v>Comps: EV/Revenue, peer 25th–75th   $322–418</c:v>
                   </c:pt>
                   <c:pt idx="6">
-                    <c:v>Comps: Walmart &amp; BJ's, selected   $452–688</c:v>
+                    <c:v>Comps: warehouse peers, selected   $359–688</c:v>
                   </c:pt>
                   <c:pt idx="7">
                     <c:v>7% growth for 10 to 100 more years   $411–780</c:v>
@@ -227,16 +227,16 @@
                   <c:v>294.226</c:v>
                 </c:pt>
                 <c:pt idx="3">
-                  <c:v>208.423</c:v>
+                  <c:v>216.342</c:v>
                 </c:pt>
                 <c:pt idx="4">
-                  <c:v>251.541</c:v>
+                  <c:v>258.757</c:v>
                 </c:pt>
                 <c:pt idx="5">
-                  <c:v>330.409</c:v>
+                  <c:v>322.495</c:v>
                 </c:pt>
                 <c:pt idx="6">
-                  <c:v>452.488</c:v>
+                  <c:v>359.346</c:v>
                 </c:pt>
                 <c:pt idx="7">
                   <c:v>410.524</c:v>
@@ -306,16 +306,16 @@
                     <c:v>DCF: WACC and growth ±0.5pp   $294–398</c:v>
                   </c:pt>
                   <c:pt idx="3">
-                    <c:v>Comps: EV/EBITDA, peer 25th–75th   $208–359</c:v>
+                    <c:v>Comps: EV/EBITDA, peer 25th–75th   $216–331</c:v>
                   </c:pt>
                   <c:pt idx="4">
-                    <c:v>Comps: P/E, peer 25th–75th   $252–408</c:v>
+                    <c:v>Comps: P/E, peer 25th–75th   $259–393</c:v>
                   </c:pt>
                   <c:pt idx="5">
-                    <c:v>Comps: EV/Revenue, peer 25th–75th   $330–423</c:v>
+                    <c:v>Comps: EV/Revenue, peer 25th–75th   $322–418</c:v>
                   </c:pt>
                   <c:pt idx="6">
-                    <c:v>Comps: Walmart &amp; BJ's, selected   $452–688</c:v>
+                    <c:v>Comps: warehouse peers, selected   $359–688</c:v>
                   </c:pt>
                   <c:pt idx="7">
                     <c:v>7% growth for 10 to 100 more years   $411–780</c:v>
@@ -340,16 +340,16 @@
                   <c:v>103.88100000000003</c:v>
                 </c:pt>
                 <c:pt idx="3">
-                  <c:v>150.923</c:v>
+                  <c:v>114.55199999999999</c:v>
                 </c:pt>
                 <c:pt idx="4">
-                  <c:v>156.61</c:v>
+                  <c:v>133.91199999999998</c:v>
                 </c:pt>
                 <c:pt idx="5">
-                  <c:v>92.59899999999999</c:v>
+                  <c:v>95.00999999999999</c:v>
                 </c:pt>
                 <c:pt idx="6">
-                  <c:v>235.26399999999995</c:v>
+                  <c:v>328.40599999999995</c:v>
                 </c:pt>
                 <c:pt idx="7">
                   <c:v>369.289</c:v>
@@ -419,16 +419,16 @@
                     <c:v>DCF: WACC and growth ±0.5pp   $294–398</c:v>
                   </c:pt>
                   <c:pt idx="3">
-                    <c:v>Comps: EV/EBITDA, peer 25th–75th   $208–359</c:v>
+                    <c:v>Comps: EV/EBITDA, peer 25th–75th   $216–331</c:v>
                   </c:pt>
                   <c:pt idx="4">
-                    <c:v>Comps: P/E, peer 25th–75th   $252–408</c:v>
+                    <c:v>Comps: P/E, peer 25th–75th   $259–393</c:v>
                   </c:pt>
                   <c:pt idx="5">
-                    <c:v>Comps: EV/Revenue, peer 25th–75th   $330–423</c:v>
+                    <c:v>Comps: EV/Revenue, peer 25th–75th   $322–418</c:v>
                   </c:pt>
                   <c:pt idx="6">
-                    <c:v>Comps: Walmart &amp; BJ's, selected   $452–688</c:v>
+                    <c:v>Comps: warehouse peers, selected   $359–688</c:v>
                   </c:pt>
                   <c:pt idx="7">
                     <c:v>7% growth for 10 to 100 more years   $411–780</c:v>
@@ -1175,7 +1175,7 @@
           <a:p>
             <a:r>
               <a:rPr lang="en-US" dirty="0"/>
-              <a:t>Football field of every valuation method. Base-case DCF $337 (WACC 8.38%, terminal growth 3.0%). Peer-median multiples imply $240 (EV/EBITDA) and $280 (P/E); Walmart and BJ's multiples $452–688. Even 7% growth for 100 years after FY2029 gives only $780. Operating sensitivities move value only $299–380.</a:t>
+              <a:t>Football field of every valuation method. Base-case DCF $337 (WACC 8.38%, terminal growth 3.0%). Peer-median multiples imply $243 (EV/EBITDA) and $313 (P/E); the membership-warehouse range with Walmart as the ceiling is $359–688. Even 7% growth for 100 years after FY2029 gives only $780. Operating sensitivities move value only $299–380.</a:t>
             </a:r>
             <a:endParaRPr lang="en-US" dirty="0"/>
           </a:p>
@@ -2849,7 +2849,7 @@
                 <a:ea typeface="Calibri" pitchFamily="34" charset="-122"/>
                 <a:cs typeface="Calibri" pitchFamily="34" charset="-120"/>
               </a:rPr>
-              <a:t>Costco trades at 57x LTM earnings; the peer median is 16x.</a:t>
+              <a:t>Costco trades at 57x LTM earnings; the peer median is 18x.</a:t>
             </a:r>
             <a:endParaRPr lang="en-US" sz="1150" dirty="0"/>
           </a:p>
@@ -3525,7 +3525,7 @@
                 <a:ea typeface="Calibri" pitchFamily="34" charset="-122"/>
                 <a:cs typeface="Calibri" pitchFamily="34" charset="-120"/>
               </a:rPr>
-              <a:t>Independent academic research and valuation case study; not investment advice.  Sources: model outputs (outputs/tables); peers WMT, BJ, TGT, KR, DG, DLTR from SEC filings; FRED; Damodaran.</a:t>
+              <a:t>Independent academic research and valuation case study; not investment advice.  Sources: model outputs (outputs/tables); seven peers from SEC filings; FRED; Damodaran.</a:t>
             </a:r>
             <a:endParaRPr lang="en-US" sz="750" dirty="0"/>
           </a:p>
@@ -4176,7 +4176,7 @@
                 <a:ea typeface="Calibri" pitchFamily="34" charset="-122"/>
                 <a:cs typeface="Calibri" pitchFamily="34" charset="-120"/>
               </a:rPr>
-              <a:t>A fall toward $452–688, the comps range anchored on Walmart and BJ's.</a:t>
+              <a:t>A fall toward $359–688, the comps range anchored on the warehouse-club peers.</a:t>
             </a:r>
             <a:endParaRPr lang="en-US" sz="1200" dirty="0"/>
           </a:p>

</xml_diff>